<commit_message>
feat: embed showcase imagery in the deck + adopt ecosystem research lessons
- image_grid layout: slide.images rendered as captioned cards (normalized
  16:9 assets, explicit missing_asset notes, alt text on every picture)
- example deck grows to 14 slides: 12-host logo wall + 4 real showcase
  cases (blender lookdev, marmoset PBR, hunyuan3d, zbrush retopo)
- a11y: _add_picture sets alt text everywhere; inventory_deck tool reports
  notes coverage + alt gaps (14/14 notes, 0 alt gaps on the showcase deck)
- skill: decision rules (template-first, narrative-before-code, layout by
  name) + known limits (no animations/gradients/combo-charts, webp
  rejected) + learnings.md loop — distilled from document-pptx,
  IBM/chuk-mcp-pptx, and Tencent/Youtu-agent ppt_gen research
- fix: render_deck resolves paths before COM (PowerPoint's cwd differs from
  ours — relative paths hit 0x80070003, caught in this session)
</commit_message>
<xml_diff>
--- a/examples/output/review-demo/draft-review-dcc-mcp-framework.pptx
+++ b/examples/output/review-demo/draft-review-dcc-mcp-framework.pptx
@@ -4441,7 +4441,7 @@
       </p:sp>
       <p:pic>
         <p:nvPicPr>
-          <p:cNvPr id="5" name="Picture 4" descr="slide-04.png"/>
+          <p:cNvPr id="5" name="Picture 4" descr="examples/output/previews/slide-04.png"/>
           <p:cNvPicPr>
             <a:picLocks noChangeAspect="1"/>
           </p:cNvPicPr>
@@ -4461,6 +4461,7 @@
           <a:prstGeom prst="rect">
             <a:avLst/>
           </a:prstGeom>
+          <a:effectLst/>
         </p:spPr>
       </p:pic>
       <p:sp>
@@ -4790,7 +4791,7 @@
       </p:sp>
       <p:pic>
         <p:nvPicPr>
-          <p:cNvPr id="5" name="Picture 4" descr="slide-06.png"/>
+          <p:cNvPr id="5" name="Picture 4" descr="examples/output/previews/slide-06.png"/>
           <p:cNvPicPr>
             <a:picLocks noChangeAspect="1"/>
           </p:cNvPicPr>
@@ -4810,6 +4811,7 @@
           <a:prstGeom prst="rect">
             <a:avLst/>
           </a:prstGeom>
+          <a:effectLst/>
         </p:spPr>
       </p:pic>
       <p:sp>

</xml_diff>

<commit_message>
feat: embed showcase imagery in the deck + adopt ecosystem research lessons (#7)
- image_grid layout: slide.images rendered as captioned cards (normalized
  16:9 assets, explicit missing_asset notes, alt text on every picture)
- example deck grows to 14 slides: 12-host logo wall + 4 real showcase
  cases (blender lookdev, marmoset PBR, hunyuan3d, zbrush retopo)
- a11y: _add_picture sets alt text everywhere; inventory_deck tool reports
  notes coverage + alt gaps (14/14 notes, 0 alt gaps on the showcase deck)
- skill: decision rules (template-first, narrative-before-code, layout by
  name) + known limits (no animations/gradients/combo-charts, webp
  rejected) + learnings.md loop — distilled from document-pptx,
  IBM/chuk-mcp-pptx, and Tencent/Youtu-agent ppt_gen research
- fix: render_deck resolves paths before COM (PowerPoint's cwd differs from
  ours — relative paths hit 0x80070003, caught in this session)
</commit_message>
<xml_diff>
--- a/examples/output/review-demo/draft-review-dcc-mcp-framework.pptx
+++ b/examples/output/review-demo/draft-review-dcc-mcp-framework.pptx
@@ -4441,7 +4441,7 @@
       </p:sp>
       <p:pic>
         <p:nvPicPr>
-          <p:cNvPr id="5" name="Picture 4" descr="slide-04.png"/>
+          <p:cNvPr id="5" name="Picture 4" descr="examples/output/previews/slide-04.png"/>
           <p:cNvPicPr>
             <a:picLocks noChangeAspect="1"/>
           </p:cNvPicPr>
@@ -4461,6 +4461,7 @@
           <a:prstGeom prst="rect">
             <a:avLst/>
           </a:prstGeom>
+          <a:effectLst/>
         </p:spPr>
       </p:pic>
       <p:sp>
@@ -4790,7 +4791,7 @@
       </p:sp>
       <p:pic>
         <p:nvPicPr>
-          <p:cNvPr id="5" name="Picture 4" descr="slide-06.png"/>
+          <p:cNvPr id="5" name="Picture 4" descr="examples/output/previews/slide-06.png"/>
           <p:cNvPicPr>
             <a:picLocks noChangeAspect="1"/>
           </p:cNvPicPr>
@@ -4810,6 +4811,7 @@
           <a:prstGeom prst="rect">
             <a:avLst/>
           </a:prstGeom>
+          <a:effectLst/>
         </p:spPr>
       </p:pic>
       <p:sp>

</xml_diff>